<commit_message>
Convert CCT manuscript equations to Word-native OMML via pandoc
- generate_cct_docx.py now renders $...$ and $$...$$ LaTeX math as Word-native Office Math Markup (OMML) using pandoc.

- build_tables_docx.py deep-copies table XML so OMML equations are preserved in the separate tables docx.

- build_figures_pptx.py converts inline math to Unicode in figure captions for the editable PPTX.

- Regenerate KOTHA_Framework_CCT.docx, figures.pptx, tables.docx, and the submission/researchsquare zips.

Co-Authored-By: Tatsuki Onishi <bougtoir@gmail.com>
</commit_message>
<xml_diff>
--- a/rct-decomposition/KOTHA_Framework_CCT_figures.pptx
+++ b/rct-decomposition/KOTHA_Framework_CCT_figures.pptx
@@ -3488,7 +3488,7 @@
               <a:defRPr sz="1400"/>
             </a:pPr>
             <a:r>
-              <a:t>Figure 4. Forest plot for magnesium in AMI. Individual study odds ratios are shown with 95% confidence intervals, color-coded by era. Pooled estimates include frequentist random-effects (pre-ISIS-4 and all trials) and Bayesian integrated estimates at selected discounting levels ($\alpha$ = 0.3, 0.5, 1.0).</a:t>
+              <a:t>Figure 4. Forest plot for magnesium in AMI. Individual study odds ratios are shown with 95% confidence intervals, color-coded by era. Pooled estimates include frequentist random-effects (pre-ISIS-4 and all trials) and Bayesian integrated estimates at selected discounting levels (α = 0.3, 0.5, 1.0).</a:t>
             </a:r>
           </a:p>
         </p:txBody>
@@ -3696,7 +3696,7 @@
               <a:defRPr sz="1400"/>
             </a:pPr>
             <a:r>
-              <a:t>Figure 6. Forest plot for statins in heart failure. Individual study hazard ratios are shown with 95% confidence intervals, grouped by design. Pooled estimates include design-specific frequentist pooling and KOTHA-integrated estimates at selected discounting levels ($\alpha$ = 0.1, 0.3, 0.5).</a:t>
+              <a:t>Figure 6. Forest plot for statins in heart failure. Individual study hazard ratios are shown with 95% confidence intervals, grouped by design. Pooled estimates include design-specific frequentist pooling and KOTHA-integrated estimates at selected discounting levels (α = 0.1, 0.3, 0.5).</a:t>
             </a:r>
           </a:p>
         </p:txBody>
@@ -3800,7 +3800,7 @@
               <a:defRPr sz="1400"/>
             </a:pPr>
             <a:r>
-              <a:t>Figure 7. Sensitivity analysis of Bayesian integration to the discounting parameter $\alpha$. (A) Magnesium in AMI. (B) Statins in HF. Three posterior probability thresholds are shown: P(effect &lt; 1.0), P(effect &lt; 0.90), and P(effect &lt; 0.80). Horizontal dashed line indicates 95% probability.</a:t>
+              <a:t>Figure 7. Sensitivity analysis of Bayesian integration to the discounting parameter α. (A) Magnesium in AMI. (B) Statins in HF. Three posterior probability thresholds are shown: P(effect &lt; 1.0), P(effect &lt; 0.90), and P(effect &lt; 0.80). Horizontal dashed line indicates 95% probability.</a:t>
             </a:r>
           </a:p>
         </p:txBody>

</xml_diff>